<commit_message>
Adiciona o bloco 35, loop de fumpa a 135 BPM, com o click do bloco 30.
Co-Authored-By: Claude Opus 5.5 <noreply@anthropic.com>
</commit_message>
<xml_diff>
--- a/VS - ROTA/REPERTÓRIO/Repertório Rota do Chopp VS.pptx
+++ b/VS - ROTA/REPERTÓRIO/Repertório Rota do Chopp VS.pptx
@@ -43,6 +43,7 @@
     <p:sldId id="477" r:id="rId34"/>
     <p:sldId id="478" r:id="rId35"/>
     <p:sldId id="479" r:id="rId36"/>
+    <p:sldId id="481" r:id="rId43"/>
   </p:sldIdLst>
   <p:sldSz cx="12192000" cy="6858000"/>
   <p:notesSz cx="6858000" cy="9144000"/>
@@ -10459,6 +10460,100 @@
 </p:sld>
 </file>
 
+<file path=ppt/slides/slide36.xml><?xml version="1.0" encoding="utf-8"?>
+<p:sld xmlns:a="http://schemas.openxmlformats.org/drawingml/2006/main" xmlns:r="http://schemas.openxmlformats.org/officeDocument/2006/relationships" xmlns:p="http://schemas.openxmlformats.org/presentationml/2006/main">
+  <p:cSld>
+    <p:spTree>
+      <p:nvGrpSpPr>
+        <p:cNvPr id="1" name=""/>
+        <p:cNvGrpSpPr/>
+        <p:nvPr/>
+      </p:nvGrpSpPr>
+      <p:grpSpPr>
+        <a:xfrm>
+          <a:off x="0" y="0"/>
+          <a:ext cx="0" cy="0"/>
+          <a:chOff x="0" y="0"/>
+          <a:chExt cx="0" cy="0"/>
+        </a:xfrm>
+      </p:grpSpPr>
+      <p:sp>
+        <p:nvSpPr>
+          <p:cNvPr id="3" name="Espaço Reservado para Conteúdo 2">
+            <a:extLst>
+              <a:ext uri="{FF2B5EF4-FFF2-40B4-BE49-F238E27FC236}">
+                <a16:creationId xmlns:a16="http://schemas.microsoft.com/office/drawing/2014/main" id="{7C70BAA2-54A1-BAA9-5EF9-9F93F22AE700}"/>
+              </a:ext>
+            </a:extLst>
+          </p:cNvPr>
+          <p:cNvSpPr>
+            <a:spLocks noGrp="1"/>
+          </p:cNvSpPr>
+          <p:nvPr>
+            <p:ph idx="1"/>
+          </p:nvPr>
+        </p:nvSpPr>
+        <p:spPr>
+          <a:xfrm>
+            <a:off x="10509" y="-3937"/>
+            <a:ext cx="12181491" cy="6861937"/>
+          </a:xfrm>
+        </p:spPr>
+        <p:txBody>
+          <a:bodyPr>
+            <a:noAutofit/>
+          </a:bodyPr>
+          <a:lstStyle/>
+          <a:p>
+            <a:pPr algn="ctr">
+              <a:lnSpc>
+                <a:spcPct val="100000"/>
+              </a:lnSpc>
+              <a:buNone/>
+            </a:pPr>
+            <a:r>
+              <a:rPr lang="en-US" sz="8800" dirty="0">
+                <a:solidFill>
+                  <a:srgbClr val="FF0000"/>
+                </a:solidFill>
+                <a:cs typeface="Arial" panose="020B0604020202020204" pitchFamily="34" charset="0"/>
+              </a:rPr>
+              <a:t>VS BLOCO 35</a:t>
+            </a:r>
+          </a:p>
+          <a:p>
+            <a:pPr marL="36000" indent="-252000" algn="ctr">
+              <a:lnSpc>
+                <a:spcPct val="100000"/>
+              </a:lnSpc>
+              <a:spcBef>
+                <a:spcPts val="0"/>
+              </a:spcBef>
+              <a:buNone/>
+            </a:pPr>
+            <a:r>
+              <a:rPr lang="pt-BR" sz="7200" dirty="0"/>
+              <a:t>Loop de Fumpa </a:t>
+            </a:r>
+            <a:r>
+              <a:rPr lang="pt-BR" sz="7200" dirty="0">
+                <a:solidFill>
+                  <a:srgbClr val="FF0000"/>
+                </a:solidFill>
+              </a:rPr>
+              <a:t>135 BPM</a:t>
+            </a:r>
+          </a:p>
+        </p:txBody>
+      </p:sp>
+    </p:spTree>
+  </p:cSld>
+  <p:clrMapOvr>
+    <a:masterClrMapping/>
+  </p:clrMapOvr>
+</p:sld>
+</file>
+
 <file path=ppt/slides/slide4.xml><?xml version="1.0" encoding="utf-8"?>
 <p:sld xmlns:a="http://schemas.openxmlformats.org/drawingml/2006/main" xmlns:r="http://schemas.openxmlformats.org/officeDocument/2006/relationships" xmlns:p="http://schemas.openxmlformats.org/presentationml/2006/main">
   <p:cSld>

</xml_diff>

<commit_message>
Adiciona o bloco 36, A FESTA É COM O ROTA (click e VS no FECHADO).
Co-Authored-By: Claude Opus 5.5 <noreply@anthropic.com>
</commit_message>
<xml_diff>
--- a/VS - ROTA/REPERTÓRIO/Repertório Rota do Chopp VS.pptx
+++ b/VS - ROTA/REPERTÓRIO/Repertório Rota do Chopp VS.pptx
@@ -44,6 +44,7 @@
     <p:sldId id="478" r:id="rId35"/>
     <p:sldId id="479" r:id="rId36"/>
     <p:sldId id="481" r:id="rId43"/>
+    <p:sldId id="482" r:id="rId44"/>
   </p:sldIdLst>
   <p:sldSz cx="12192000" cy="6858000"/>
   <p:notesSz cx="6858000" cy="9144000"/>
@@ -10554,6 +10555,100 @@
 </p:sld>
 </file>
 
+<file path=ppt/slides/slide37.xml><?xml version="1.0" encoding="utf-8"?>
+<p:sld xmlns:a="http://schemas.openxmlformats.org/drawingml/2006/main" xmlns:r="http://schemas.openxmlformats.org/officeDocument/2006/relationships" xmlns:p="http://schemas.openxmlformats.org/presentationml/2006/main">
+  <p:cSld>
+    <p:spTree>
+      <p:nvGrpSpPr>
+        <p:cNvPr id="1" name=""/>
+        <p:cNvGrpSpPr/>
+        <p:nvPr/>
+      </p:nvGrpSpPr>
+      <p:grpSpPr>
+        <a:xfrm>
+          <a:off x="0" y="0"/>
+          <a:ext cx="0" cy="0"/>
+          <a:chOff x="0" y="0"/>
+          <a:chExt cx="0" cy="0"/>
+        </a:xfrm>
+      </p:grpSpPr>
+      <p:sp>
+        <p:nvSpPr>
+          <p:cNvPr id="3" name="Espaço Reservado para Conteúdo 2">
+            <a:extLst>
+              <a:ext uri="{FF2B5EF4-FFF2-40B4-BE49-F238E27FC236}">
+                <a16:creationId xmlns:a16="http://schemas.microsoft.com/office/drawing/2014/main" id="{7C70BAA2-54A1-BAA9-5EF9-9F93F22AE700}"/>
+              </a:ext>
+            </a:extLst>
+          </p:cNvPr>
+          <p:cNvSpPr>
+            <a:spLocks noGrp="1"/>
+          </p:cNvSpPr>
+          <p:nvPr>
+            <p:ph idx="1"/>
+          </p:nvPr>
+        </p:nvSpPr>
+        <p:spPr>
+          <a:xfrm>
+            <a:off x="10509" y="-3937"/>
+            <a:ext cx="12181491" cy="6861937"/>
+          </a:xfrm>
+        </p:spPr>
+        <p:txBody>
+          <a:bodyPr>
+            <a:noAutofit/>
+          </a:bodyPr>
+          <a:lstStyle/>
+          <a:p>
+            <a:pPr algn="ctr">
+              <a:lnSpc>
+                <a:spcPct val="100000"/>
+              </a:lnSpc>
+              <a:buNone/>
+            </a:pPr>
+            <a:r>
+              <a:rPr lang="en-US" sz="8800" dirty="0">
+                <a:solidFill>
+                  <a:srgbClr val="FF0000"/>
+                </a:solidFill>
+                <a:cs typeface="Arial" panose="020B0604020202020204" pitchFamily="34" charset="0"/>
+              </a:rPr>
+              <a:t>VS BLOCO 36</a:t>
+            </a:r>
+          </a:p>
+          <a:p>
+            <a:pPr marL="36000" indent="-252000" algn="ctr">
+              <a:lnSpc>
+                <a:spcPct val="100000"/>
+              </a:lnSpc>
+              <a:spcBef>
+                <a:spcPts val="0"/>
+              </a:spcBef>
+              <a:buNone/>
+            </a:pPr>
+            <a:r>
+              <a:rPr lang="pt-BR" sz="7200" dirty="0"/>
+              <a:t>A Festa É com o Rota </a:t>
+            </a:r>
+            <a:r>
+              <a:rPr lang="pt-BR" sz="7200" dirty="0">
+                <a:solidFill>
+                  <a:srgbClr val="FF0000"/>
+                </a:solidFill>
+              </a:rPr>
+              <a:t>??</a:t>
+            </a:r>
+          </a:p>
+        </p:txBody>
+      </p:sp>
+    </p:spTree>
+  </p:cSld>
+  <p:clrMapOvr>
+    <a:masterClrMapping/>
+  </p:clrMapOvr>
+</p:sld>
+</file>
+
 <file path=ppt/slides/slide4.xml><?xml version="1.0" encoding="utf-8"?>
 <p:sld xmlns:a="http://schemas.openxmlformats.org/drawingml/2006/main" xmlns:r="http://schemas.openxmlformats.org/officeDocument/2006/relationships" xmlns:p="http://schemas.openxmlformats.org/presentationml/2006/main">
   <p:cSld>

</xml_diff>

<commit_message>
Adiciona os loops de fumpa a 140 BPM (bloco 36) e de vaneira a 97 BPM (bloco 37).
Os dois entram depois dos loops que já havia; A FESTA É COM O ROTA desce
para o bloco 38. O click de 140 é o do bloco 35 esticado; o click e a
percussão de 97 são os do bloco 34 esticados. Leva também os ajustes feitos
no Reaper (volumes dos faders de grupo, saídas de hardware, cores).

Co-Authored-By: Claude Opus 5.5 <noreply@anthropic.com>
</commit_message>
<xml_diff>
--- a/VS - ROTA/REPERTÓRIO/Repertório Rota do Chopp VS.pptx
+++ b/VS - ROTA/REPERTÓRIO/Repertório Rota do Chopp VS.pptx
@@ -45,6 +45,8 @@
     <p:sldId id="479" r:id="rId36"/>
     <p:sldId id="481" r:id="rId43"/>
     <p:sldId id="482" r:id="rId44"/>
+    <p:sldId id="483" r:id="rId45"/>
+    <p:sldId id="484" r:id="rId46"/>
   </p:sldIdLst>
   <p:sldSz cx="12192000" cy="6858000"/>
   <p:notesSz cx="6858000" cy="9144000"/>
@@ -10628,6 +10630,194 @@
             </a:pPr>
             <a:r>
               <a:rPr lang="pt-BR" sz="7200" dirty="0"/>
+              <a:t>Loop de Fumpa </a:t>
+            </a:r>
+            <a:r>
+              <a:rPr lang="pt-BR" sz="7200" dirty="0">
+                <a:solidFill>
+                  <a:srgbClr val="FF0000"/>
+                </a:solidFill>
+              </a:rPr>
+              <a:t>140 BPM</a:t>
+            </a:r>
+          </a:p>
+        </p:txBody>
+      </p:sp>
+    </p:spTree>
+  </p:cSld>
+  <p:clrMapOvr>
+    <a:masterClrMapping/>
+  </p:clrMapOvr>
+</p:sld>
+</file>
+
+<file path=ppt/slides/slide38.xml><?xml version="1.0" encoding="utf-8"?>
+<p:sld xmlns:a="http://schemas.openxmlformats.org/drawingml/2006/main" xmlns:r="http://schemas.openxmlformats.org/officeDocument/2006/relationships" xmlns:p="http://schemas.openxmlformats.org/presentationml/2006/main">
+  <p:cSld>
+    <p:spTree>
+      <p:nvGrpSpPr>
+        <p:cNvPr id="1" name=""/>
+        <p:cNvGrpSpPr/>
+        <p:nvPr/>
+      </p:nvGrpSpPr>
+      <p:grpSpPr>
+        <a:xfrm>
+          <a:off x="0" y="0"/>
+          <a:ext cx="0" cy="0"/>
+          <a:chOff x="0" y="0"/>
+          <a:chExt cx="0" cy="0"/>
+        </a:xfrm>
+      </p:grpSpPr>
+      <p:sp>
+        <p:nvSpPr>
+          <p:cNvPr id="3" name="Espaço Reservado para Conteúdo 2">
+            <a:extLst>
+              <a:ext uri="{FF2B5EF4-FFF2-40B4-BE49-F238E27FC236}">
+                <a16:creationId xmlns:a16="http://schemas.microsoft.com/office/drawing/2014/main" id="{7C70BAA2-54A1-BAA9-5EF9-9F93F22AE700}"/>
+              </a:ext>
+            </a:extLst>
+          </p:cNvPr>
+          <p:cNvSpPr>
+            <a:spLocks noGrp="1"/>
+          </p:cNvSpPr>
+          <p:nvPr>
+            <p:ph idx="1"/>
+          </p:nvPr>
+        </p:nvSpPr>
+        <p:spPr>
+          <a:xfrm>
+            <a:off x="10509" y="-3937"/>
+            <a:ext cx="12181491" cy="6861937"/>
+          </a:xfrm>
+        </p:spPr>
+        <p:txBody>
+          <a:bodyPr>
+            <a:noAutofit/>
+          </a:bodyPr>
+          <a:lstStyle/>
+          <a:p>
+            <a:pPr algn="ctr">
+              <a:lnSpc>
+                <a:spcPct val="100000"/>
+              </a:lnSpc>
+              <a:buNone/>
+            </a:pPr>
+            <a:r>
+              <a:rPr lang="en-US" sz="8800" dirty="0">
+                <a:solidFill>
+                  <a:srgbClr val="FF0000"/>
+                </a:solidFill>
+                <a:cs typeface="Arial" panose="020B0604020202020204" pitchFamily="34" charset="0"/>
+              </a:rPr>
+              <a:t>VS BLOCO 37</a:t>
+            </a:r>
+          </a:p>
+          <a:p>
+            <a:pPr marL="36000" indent="-252000" algn="ctr">
+              <a:lnSpc>
+                <a:spcPct val="100000"/>
+              </a:lnSpc>
+              <a:spcBef>
+                <a:spcPts val="0"/>
+              </a:spcBef>
+              <a:buNone/>
+            </a:pPr>
+            <a:r>
+              <a:rPr lang="pt-BR" sz="7200" dirty="0"/>
+              <a:t>Loop de Vaneira </a:t>
+            </a:r>
+            <a:r>
+              <a:rPr lang="pt-BR" sz="7200" dirty="0">
+                <a:solidFill>
+                  <a:srgbClr val="FF0000"/>
+                </a:solidFill>
+              </a:rPr>
+              <a:t>97 BPM</a:t>
+            </a:r>
+          </a:p>
+        </p:txBody>
+      </p:sp>
+    </p:spTree>
+  </p:cSld>
+  <p:clrMapOvr>
+    <a:masterClrMapping/>
+  </p:clrMapOvr>
+</p:sld>
+</file>
+
+<file path=ppt/slides/slide39.xml><?xml version="1.0" encoding="utf-8"?>
+<p:sld xmlns:a="http://schemas.openxmlformats.org/drawingml/2006/main" xmlns:r="http://schemas.openxmlformats.org/officeDocument/2006/relationships" xmlns:p="http://schemas.openxmlformats.org/presentationml/2006/main">
+  <p:cSld>
+    <p:spTree>
+      <p:nvGrpSpPr>
+        <p:cNvPr id="1" name=""/>
+        <p:cNvGrpSpPr/>
+        <p:nvPr/>
+      </p:nvGrpSpPr>
+      <p:grpSpPr>
+        <a:xfrm>
+          <a:off x="0" y="0"/>
+          <a:ext cx="0" cy="0"/>
+          <a:chOff x="0" y="0"/>
+          <a:chExt cx="0" cy="0"/>
+        </a:xfrm>
+      </p:grpSpPr>
+      <p:sp>
+        <p:nvSpPr>
+          <p:cNvPr id="3" name="Espaço Reservado para Conteúdo 2">
+            <a:extLst>
+              <a:ext uri="{FF2B5EF4-FFF2-40B4-BE49-F238E27FC236}">
+                <a16:creationId xmlns:a16="http://schemas.microsoft.com/office/drawing/2014/main" id="{7C70BAA2-54A1-BAA9-5EF9-9F93F22AE700}"/>
+              </a:ext>
+            </a:extLst>
+          </p:cNvPr>
+          <p:cNvSpPr>
+            <a:spLocks noGrp="1"/>
+          </p:cNvSpPr>
+          <p:nvPr>
+            <p:ph idx="1"/>
+          </p:nvPr>
+        </p:nvSpPr>
+        <p:spPr>
+          <a:xfrm>
+            <a:off x="10509" y="-3937"/>
+            <a:ext cx="12181491" cy="6861937"/>
+          </a:xfrm>
+        </p:spPr>
+        <p:txBody>
+          <a:bodyPr>
+            <a:noAutofit/>
+          </a:bodyPr>
+          <a:lstStyle/>
+          <a:p>
+            <a:pPr algn="ctr">
+              <a:lnSpc>
+                <a:spcPct val="100000"/>
+              </a:lnSpc>
+              <a:buNone/>
+            </a:pPr>
+            <a:r>
+              <a:rPr lang="en-US" sz="8800" dirty="0">
+                <a:solidFill>
+                  <a:srgbClr val="FF0000"/>
+                </a:solidFill>
+                <a:cs typeface="Arial" panose="020B0604020202020204" pitchFamily="34" charset="0"/>
+              </a:rPr>
+              <a:t>VS BLOCO 38</a:t>
+            </a:r>
+          </a:p>
+          <a:p>
+            <a:pPr marL="36000" indent="-252000" algn="ctr">
+              <a:lnSpc>
+                <a:spcPct val="100000"/>
+              </a:lnSpc>
+              <a:spcBef>
+                <a:spcPts val="0"/>
+              </a:spcBef>
+              <a:buNone/>
+            </a:pPr>
+            <a:r>
+              <a:rPr lang="pt-BR" sz="7200" dirty="0"/>
               <a:t>A Festa É com o Rota </a:t>
             </a:r>
             <a:r>

</xml_diff>